<commit_message>
docs: Phase 19, FR-4600, and a feature map that tells the truth again
Roadmap section and status for the workshop configuring itself, eight FR-4600
requirements traced (331 traced, 328 automated), and the feature map
corrected for what Phases 15 to 18 built: supplier payments, fleet
agreements, consolidated invoicing, customer sign-up, the Ask page,
estimates from inspections and accepting the plan. Counts and deck rebuilt.

Co-Authored-By: Claude Fable 5.1 <noreply@anthropic.com>
Claude-Session: https://claude.ai/code/session_01BE9pUPtds3ZzUZiN8bmAhQ
</commit_message>
<xml_diff>
--- a/docs/Carnet-Presentation.pptx
+++ b/docs/Carnet-Presentation.pptx
@@ -7437,7 +7437,7 @@
                 </a:solidFill>
                 <a:latin typeface="Georgia"/>
               </a:rPr>
-              <a:t>77</a:t>
+              <a:t>92</a:t>
             </a:r>
           </a:p>
         </p:txBody>
@@ -7642,7 +7642,7 @@
                 </a:solidFill>
                 <a:latin typeface="Georgia"/>
               </a:rPr>
-              <a:t>114</a:t>
+              <a:t>121</a:t>
             </a:r>
           </a:p>
         </p:txBody>
@@ -7847,7 +7847,7 @@
                 </a:solidFill>
                 <a:latin typeface="Georgia"/>
               </a:rPr>
-              <a:t>1,013</a:t>
+              <a:t>1,230</a:t>
             </a:r>
           </a:p>
         </p:txBody>
@@ -8052,7 +8052,7 @@
                 </a:solidFill>
                 <a:latin typeface="Georgia"/>
               </a:rPr>
-              <a:t>23</a:t>
+              <a:t>30</a:t>
             </a:r>
           </a:p>
         </p:txBody>
@@ -8257,7 +8257,7 @@
                 </a:solidFill>
                 <a:latin typeface="Georgia"/>
               </a:rPr>
-              <a:t>357</a:t>
+              <a:t>415</a:t>
             </a:r>
           </a:p>
         </p:txBody>
@@ -8887,7 +8887,7 @@
         <p:spPr>
           <a:xfrm>
             <a:off x="822960" y="2468880"/>
-            <a:ext cx="9173379" cy="548640"/>
+            <a:ext cx="9678998" cy="548640"/>
           </a:xfrm>
           <a:prstGeom prst="rect">
             <a:avLst/>
@@ -8931,7 +8931,7 @@
         <p:spPr>
           <a:xfrm>
             <a:off x="1005840" y="2615184"/>
-            <a:ext cx="8899059" cy="320040"/>
+            <a:ext cx="9404678" cy="320040"/>
           </a:xfrm>
           <a:prstGeom prst="rect">
             <a:avLst/>
@@ -8956,7 +8956,7 @@
                 </a:solidFill>
                 <a:latin typeface="Segoe UI"/>
               </a:rPr>
-              <a:t>Built 127</a:t>
+              <a:t>Built 134</a:t>
             </a:r>
           </a:p>
         </p:txBody>
@@ -8969,8 +8969,8 @@
         </p:nvSpPr>
         <p:spPr>
           <a:xfrm>
-            <a:off x="9996339" y="2468880"/>
-            <a:ext cx="144462" cy="548640"/>
+            <a:off x="10501958" y="2468880"/>
+            <a:ext cx="72231" cy="548640"/>
           </a:xfrm>
           <a:prstGeom prst="rect">
             <a:avLst/>
@@ -9013,8 +9013,8 @@
         </p:nvSpPr>
         <p:spPr>
           <a:xfrm>
-            <a:off x="10140801" y="2468880"/>
-            <a:ext cx="1227932" cy="548640"/>
+            <a:off x="10574189" y="2468880"/>
+            <a:ext cx="794544" cy="548640"/>
           </a:xfrm>
           <a:prstGeom prst="rect">
             <a:avLst/>
@@ -9057,45 +9057,6 @@
         </p:nvSpPr>
         <p:spPr>
           <a:xfrm>
-            <a:off x="10323681" y="2615184"/>
-            <a:ext cx="953612" cy="320040"/>
-          </a:xfrm>
-          <a:prstGeom prst="rect">
-            <a:avLst/>
-          </a:prstGeom>
-          <a:noFill/>
-        </p:spPr>
-        <p:txBody>
-          <a:bodyPr wrap="square" anchor="t" lIns="0" rIns="0" tIns="0" bIns="0">
-            <a:spAutoFit/>
-          </a:bodyPr>
-          <a:lstStyle/>
-          <a:p>
-            <a:pPr algn="l">
-              <a:lnSpc>
-                <a:spcPct val="115000"/>
-              </a:lnSpc>
-            </a:pPr>
-            <a:r>
-              <a:rPr sz="1300" b="1">
-                <a:solidFill>
-                  <a:srgbClr val="535E60"/>
-                </a:solidFill>
-                <a:latin typeface="Segoe UI"/>
-              </a:rPr>
-              <a:t>Missing 17</a:t>
-            </a:r>
-          </a:p>
-        </p:txBody>
-      </p:sp>
-      <p:sp>
-        <p:nvSpPr>
-          <p:cNvPr id="11" name="TextBox 10"/>
-          <p:cNvSpPr txBox="1"/>
-          <p:nvPr/>
-        </p:nvSpPr>
-        <p:spPr>
-          <a:xfrm>
             <a:off x="822960" y="3246120"/>
             <a:ext cx="10424160" cy="548640"/>
           </a:xfrm>
@@ -9129,7 +9090,7 @@
       </p:sp>
       <p:sp>
         <p:nvSpPr>
-          <p:cNvPr id="12" name="Rectangle 11"/>
+          <p:cNvPr id="11" name="Rectangle 10"/>
           <p:cNvSpPr/>
           <p:nvPr/>
         </p:nvSpPr>
@@ -9173,7 +9134,7 @@
       </p:sp>
       <p:sp>
         <p:nvSpPr>
-          <p:cNvPr id="13" name="TextBox 12"/>
+          <p:cNvPr id="12" name="TextBox 11"/>
           <p:cNvSpPr txBox="1"/>
           <p:nvPr/>
         </p:nvSpPr>
@@ -9221,7 +9182,7 @@
       </p:sp>
       <p:sp>
         <p:nvSpPr>
-          <p:cNvPr id="14" name="Rectangle 13"/>
+          <p:cNvPr id="13" name="Rectangle 12"/>
           <p:cNvSpPr/>
           <p:nvPr/>
         </p:nvSpPr>
@@ -9265,7 +9226,7 @@
       </p:sp>
       <p:sp>
         <p:nvSpPr>
-          <p:cNvPr id="15" name="TextBox 14"/>
+          <p:cNvPr id="14" name="TextBox 13"/>
           <p:cNvSpPr txBox="1"/>
           <p:nvPr/>
         </p:nvSpPr>
@@ -9313,7 +9274,7 @@
       </p:sp>
       <p:sp>
         <p:nvSpPr>
-          <p:cNvPr id="16" name="Rectangle 15"/>
+          <p:cNvPr id="15" name="Rectangle 14"/>
           <p:cNvSpPr/>
           <p:nvPr/>
         </p:nvSpPr>
@@ -9357,7 +9318,7 @@
       </p:sp>
       <p:sp>
         <p:nvSpPr>
-          <p:cNvPr id="17" name="TextBox 16"/>
+          <p:cNvPr id="16" name="TextBox 15"/>
           <p:cNvSpPr txBox="1"/>
           <p:nvPr/>
         </p:nvSpPr>
@@ -9405,7 +9366,7 @@
       </p:sp>
       <p:sp>
         <p:nvSpPr>
-          <p:cNvPr id="18" name="TextBox 17"/>
+          <p:cNvPr id="17" name="TextBox 16"/>
           <p:cNvSpPr txBox="1"/>
           <p:nvPr/>
         </p:nvSpPr>
@@ -9444,7 +9405,7 @@
       </p:sp>
       <p:sp>
         <p:nvSpPr>
-          <p:cNvPr id="19" name="TextBox 18"/>
+          <p:cNvPr id="18" name="TextBox 17"/>
           <p:cNvSpPr txBox="1"/>
           <p:nvPr/>
         </p:nvSpPr>

</xml_diff>

<commit_message>
docs: Phase 20, FR-4700, and five more feature-map rows that read Built
Roadmap section and status for the vehicle's paperwork, eight FR-4700
requirements traced (339 traced, 336 automated), and the feature map's
satisfaction, preferred technician, insurance, photos and documents rows
corrected. Counts and deck rebuilt: 139 built, 1 partial, 6 missing.

Co-Authored-By: Claude Fable 5.1 <noreply@anthropic.com>
Claude-Session: https://claude.ai/code/session_01BE9pUPtds3ZzUZiN8bmAhQ
</commit_message>
<xml_diff>
--- a/docs/Carnet-Presentation.pptx
+++ b/docs/Carnet-Presentation.pptx
@@ -7642,7 +7642,7 @@
                 </a:solidFill>
                 <a:latin typeface="Georgia"/>
               </a:rPr>
-              <a:t>121</a:t>
+              <a:t>122</a:t>
             </a:r>
           </a:p>
         </p:txBody>
@@ -7847,7 +7847,7 @@
                 </a:solidFill>
                 <a:latin typeface="Georgia"/>
               </a:rPr>
-              <a:t>1,230</a:t>
+              <a:t>1,242</a:t>
             </a:r>
           </a:p>
         </p:txBody>
@@ -8052,7 +8052,7 @@
                 </a:solidFill>
                 <a:latin typeface="Georgia"/>
               </a:rPr>
-              <a:t>30</a:t>
+              <a:t>31</a:t>
             </a:r>
           </a:p>
         </p:txBody>
@@ -8257,7 +8257,7 @@
                 </a:solidFill>
                 <a:latin typeface="Georgia"/>
               </a:rPr>
-              <a:t>415</a:t>
+              <a:t>423</a:t>
             </a:r>
           </a:p>
         </p:txBody>
@@ -8887,7 +8887,7 @@
         <p:spPr>
           <a:xfrm>
             <a:off x="822960" y="2468880"/>
-            <a:ext cx="9678998" cy="548640"/>
+            <a:ext cx="10040155" cy="548640"/>
           </a:xfrm>
           <a:prstGeom prst="rect">
             <a:avLst/>
@@ -8931,7 +8931,7 @@
         <p:spPr>
           <a:xfrm>
             <a:off x="1005840" y="2615184"/>
-            <a:ext cx="9404678" cy="320040"/>
+            <a:ext cx="9765835" cy="320040"/>
           </a:xfrm>
           <a:prstGeom prst="rect">
             <a:avLst/>
@@ -8956,7 +8956,7 @@
                 </a:solidFill>
                 <a:latin typeface="Segoe UI"/>
               </a:rPr>
-              <a:t>Built 134</a:t>
+              <a:t>Built 139</a:t>
             </a:r>
           </a:p>
         </p:txBody>
@@ -8969,7 +8969,7 @@
         </p:nvSpPr>
         <p:spPr>
           <a:xfrm>
-            <a:off x="10501958" y="2468880"/>
+            <a:off x="10863115" y="2468880"/>
             <a:ext cx="72231" cy="548640"/>
           </a:xfrm>
           <a:prstGeom prst="rect">
@@ -9013,8 +9013,8 @@
         </p:nvSpPr>
         <p:spPr>
           <a:xfrm>
-            <a:off x="10574189" y="2468880"/>
-            <a:ext cx="794544" cy="548640"/>
+            <a:off x="10935346" y="2468880"/>
+            <a:ext cx="433388" cy="548640"/>
           </a:xfrm>
           <a:prstGeom prst="rect">
             <a:avLst/>

</xml_diff>

<commit_message>
docs: Phase 21, FR-4800, the checklists ticked, and the API document itself
Roadmap section and status, six FR-4800 requirements traced with Epic R
stories (345 traced, 342 automated), the security model's and deployment
guide's before-general-availability checklists ticked where the work is
done, the runbook's restore procedure rewritten around the automated drill
and Neon's point-in-time branches, the API contract pointing at the
generated openapi.json, and the testing strategy listing the three new
probes.

Co-Authored-By: Claude Fable 5.1 <noreply@anthropic.com>
Claude-Session: https://claude.ai/code/session_01BE9pUPtds3ZzUZiN8bmAhQ
</commit_message>
<xml_diff>
--- a/docs/Carnet-Presentation.pptx
+++ b/docs/Carnet-Presentation.pptx
@@ -7847,7 +7847,7 @@
                 </a:solidFill>
                 <a:latin typeface="Georgia"/>
               </a:rPr>
-              <a:t>1,242</a:t>
+              <a:t>1,252</a:t>
             </a:r>
           </a:p>
         </p:txBody>
@@ -8052,7 +8052,7 @@
                 </a:solidFill>
                 <a:latin typeface="Georgia"/>
               </a:rPr>
-              <a:t>31</a:t>
+              <a:t>34</a:t>
             </a:r>
           </a:p>
         </p:txBody>
@@ -8257,7 +8257,7 @@
                 </a:solidFill>
                 <a:latin typeface="Georgia"/>
               </a:rPr>
-              <a:t>423</a:t>
+              <a:t>429</a:t>
             </a:r>
           </a:p>
         </p:txBody>

</xml_diff>

<commit_message>
docs: Phase 22, FR-4900, Epic S, and the assistant in the feature map
Roadmap section and status, seven FR-4900 requirements traced (352 traced,
349 automated), Epic S stories, the feature map's AI section rewritten as a
table of what is built and the one thing deferred, an addendum to ADR-0013,
and the assistant probe in the testing strategy.

Co-Authored-By: Claude Fable 5.1 <noreply@anthropic.com>
Claude-Session: https://claude.ai/code/session_01BE9pUPtds3ZzUZiN8bmAhQ
</commit_message>
<xml_diff>
--- a/docs/Carnet-Presentation.pptx
+++ b/docs/Carnet-Presentation.pptx
@@ -7642,7 +7642,7 @@
                 </a:solidFill>
                 <a:latin typeface="Georgia"/>
               </a:rPr>
-              <a:t>122</a:t>
+              <a:t>123</a:t>
             </a:r>
           </a:p>
         </p:txBody>
@@ -7847,7 +7847,7 @@
                 </a:solidFill>
                 <a:latin typeface="Georgia"/>
               </a:rPr>
-              <a:t>1,252</a:t>
+              <a:t>1,262</a:t>
             </a:r>
           </a:p>
         </p:txBody>
@@ -8052,7 +8052,7 @@
                 </a:solidFill>
                 <a:latin typeface="Georgia"/>
               </a:rPr>
-              <a:t>34</a:t>
+              <a:t>35</a:t>
             </a:r>
           </a:p>
         </p:txBody>
@@ -8257,7 +8257,7 @@
                 </a:solidFill>
                 <a:latin typeface="Georgia"/>
               </a:rPr>
-              <a:t>429</a:t>
+              <a:t>436</a:t>
             </a:r>
           </a:p>
         </p:txBody>
@@ -8887,7 +8887,7 @@
         <p:spPr>
           <a:xfrm>
             <a:off x="822960" y="2468880"/>
-            <a:ext cx="10040155" cy="548640"/>
+            <a:ext cx="10056898" cy="548640"/>
           </a:xfrm>
           <a:prstGeom prst="rect">
             <a:avLst/>
@@ -8931,7 +8931,7 @@
         <p:spPr>
           <a:xfrm>
             <a:off x="1005840" y="2615184"/>
-            <a:ext cx="9765835" cy="320040"/>
+            <a:ext cx="9782578" cy="320040"/>
           </a:xfrm>
           <a:prstGeom prst="rect">
             <a:avLst/>
@@ -8956,7 +8956,7 @@
                 </a:solidFill>
                 <a:latin typeface="Segoe UI"/>
               </a:rPr>
-              <a:t>Built 139</a:t>
+              <a:t>Built 144</a:t>
             </a:r>
           </a:p>
         </p:txBody>
@@ -8969,8 +8969,8 @@
         </p:nvSpPr>
         <p:spPr>
           <a:xfrm>
-            <a:off x="10863115" y="2468880"/>
-            <a:ext cx="72231" cy="548640"/>
+            <a:off x="10879858" y="2468880"/>
+            <a:ext cx="69839" cy="548640"/>
           </a:xfrm>
           <a:prstGeom prst="rect">
             <a:avLst/>
@@ -9013,8 +9013,8 @@
         </p:nvSpPr>
         <p:spPr>
           <a:xfrm>
-            <a:off x="10935346" y="2468880"/>
-            <a:ext cx="433388" cy="548640"/>
+            <a:off x="10949697" y="2468880"/>
+            <a:ext cx="349197" cy="548640"/>
           </a:xfrm>
           <a:prstGeom prst="rect">
             <a:avLst/>

</xml_diff>